<commit_message>
fix: resolve XML formatting issues in presentation PPTX
</commit_message>
<xml_diff>
--- a/SkillChain_Presentation.pptx
+++ b/SkillChain_Presentation.pptx
@@ -3117,7 +3117,9 @@
             <a:srgbClr val="0F172A"/>
           </a:solidFill>
           <a:ln>
-            <a:noFill/>
+            <a:solidFill>
+              <a:srgbClr val="0F172A"/>
+            </a:solidFill>
           </a:ln>
         </p:spPr>
         <p:style>
@@ -3160,7 +3162,9 @@
             <a:srgbClr val="2563EB"/>
           </a:solidFill>
           <a:ln>
-            <a:noFill/>
+            <a:solidFill>
+              <a:srgbClr val="2563EB"/>
+            </a:solidFill>
           </a:ln>
         </p:spPr>
         <p:style>
@@ -3215,7 +3219,7 @@
                 <a:solidFill>
                   <a:srgbClr val="60A5FA"/>
                 </a:solidFill>
-                <a:latin typeface="Arial"/>
+                <a:latin typeface="Calibri"/>
               </a:defRPr>
             </a:pPr>
             <a:r>
@@ -3231,7 +3235,7 @@
                 <a:solidFill>
                   <a:srgbClr val="FFFFFF"/>
                 </a:solidFill>
-                <a:latin typeface="Arial"/>
+                <a:latin typeface="Calibri"/>
               </a:defRPr>
             </a:pPr>
             <a:r>
@@ -3241,13 +3245,13 @@
           <a:p>
             <a:pPr>
               <a:spcAft>
-                <a:spcPts val="1800"/>
+                <a:spcPts val="1600"/>
               </a:spcAft>
               <a:defRPr sz="2000" b="1">
                 <a:solidFill>
                   <a:srgbClr val="E2E8F0"/>
                 </a:solidFill>
-                <a:latin typeface="Arial"/>
+                <a:latin typeface="Calibri"/>
               </a:defRPr>
             </a:pPr>
             <a:r>
@@ -3257,13 +3261,13 @@
           <a:p>
             <a:pPr>
               <a:spcAft>
-                <a:spcPts val="3200"/>
-              </a:spcAft>
-              <a:defRPr sz="1300">
+                <a:spcPts val="2800"/>
+              </a:spcAft>
+              <a:defRPr sz="1300" b="0">
                 <a:solidFill>
                   <a:srgbClr val="94A3B8"/>
                 </a:solidFill>
-                <a:latin typeface="Arial"/>
+                <a:latin typeface="Calibri"/>
               </a:defRPr>
             </a:pPr>
             <a:r>
@@ -3272,11 +3276,14 @@
           </a:p>
           <a:p>
             <a:pPr>
+              <a:spcAft>
+                <a:spcPts val="400"/>
+              </a:spcAft>
               <a:defRPr sz="1200" b="1">
                 <a:solidFill>
                   <a:srgbClr val="CBD5E1"/>
                 </a:solidFill>
-                <a:latin typeface="Arial"/>
+                <a:latin typeface="Calibri"/>
               </a:defRPr>
             </a:pPr>
             <a:r>
@@ -3321,7 +3328,9 @@
             <a:srgbClr val="0F172A"/>
           </a:solidFill>
           <a:ln>
-            <a:noFill/>
+            <a:solidFill>
+              <a:srgbClr val="0F172A"/>
+            </a:solidFill>
           </a:ln>
         </p:spPr>
         <p:style>
@@ -3369,11 +3378,14 @@
           <a:lstStyle/>
           <a:p>
             <a:pPr>
+              <a:spcAft>
+                <a:spcPts val="400"/>
+              </a:spcAft>
               <a:defRPr sz="950" b="1">
                 <a:solidFill>
                   <a:srgbClr val="60A5FA"/>
                 </a:solidFill>
-                <a:latin typeface="Arial"/>
+                <a:latin typeface="Calibri"/>
               </a:defRPr>
             </a:pPr>
             <a:r>
@@ -3405,11 +3417,14 @@
           <a:lstStyle/>
           <a:p>
             <a:pPr>
+              <a:spcAft>
+                <a:spcPts val="400"/>
+              </a:spcAft>
               <a:defRPr sz="2000" b="1">
                 <a:solidFill>
                   <a:srgbClr val="FFFFFF"/>
                 </a:solidFill>
-                <a:latin typeface="Arial"/>
+                <a:latin typeface="Calibri"/>
               </a:defRPr>
             </a:pPr>
             <a:r>
@@ -3436,7 +3451,9 @@
             <a:srgbClr val="2563EB"/>
           </a:solidFill>
           <a:ln>
-            <a:noFill/>
+            <a:solidFill>
+              <a:srgbClr val="2563EB"/>
+            </a:solidFill>
           </a:ln>
         </p:spPr>
         <p:style>
@@ -3536,7 +3553,7 @@
                 <a:solidFill>
                   <a:srgbClr val="059669"/>
                 </a:solidFill>
-                <a:latin typeface="Arial"/>
+                <a:latin typeface="Calibri"/>
               </a:defRPr>
             </a:pPr>
             <a:r>
@@ -3552,7 +3569,7 @@
                 <a:solidFill>
                   <a:srgbClr val="0F172A"/>
                 </a:solidFill>
-                <a:latin typeface="Arial"/>
+                <a:latin typeface="Calibri"/>
               </a:defRPr>
             </a:pPr>
             <a:r>
@@ -3561,31 +3578,82 @@
           </a:p>
           <a:p>
             <a:pPr>
-              <a:defRPr sz="1100">
+              <a:spcAft>
+                <a:spcPts val="400"/>
+              </a:spcAft>
+              <a:defRPr sz="1100" b="0">
                 <a:solidFill>
                   <a:srgbClr val="0F172A"/>
                 </a:solidFill>
-                <a:latin typeface="Arial"/>
-              </a:defRPr>
-            </a:pPr>
-            <a:r>
-              <a:t>• Framework: Hardhat + Mocha + Chai</a:t>
-            </a:r>
-            <a:br/>
-            <a:r>
-              <a:t>• Execution Speed: &lt; 800ms</a:t>
-            </a:r>
-            <a:br/>
-            <a:r>
-              <a:t>• Zero Flaky Tests</a:t>
-            </a:r>
-            <a:br/>
-            <a:r>
-              <a:t>• Comprehensive Revert Handling</a:t>
-            </a:r>
-            <a:br/>
-            <a:r>
-              <a:t>• Real Local Blockchain Simulation</a:t>
+                <a:latin typeface="Calibri"/>
+              </a:defRPr>
+            </a:pPr>
+            <a:r>
+              <a:t>- Framework: Hardhat + Mocha + Chai</a:t>
+            </a:r>
+          </a:p>
+          <a:p>
+            <a:pPr>
+              <a:spcAft>
+                <a:spcPts val="400"/>
+              </a:spcAft>
+              <a:defRPr sz="1100" b="0">
+                <a:solidFill>
+                  <a:srgbClr val="0F172A"/>
+                </a:solidFill>
+                <a:latin typeface="Calibri"/>
+              </a:defRPr>
+            </a:pPr>
+            <a:r>
+              <a:t>- Execution Speed: &lt; 800ms</a:t>
+            </a:r>
+          </a:p>
+          <a:p>
+            <a:pPr>
+              <a:spcAft>
+                <a:spcPts val="400"/>
+              </a:spcAft>
+              <a:defRPr sz="1100" b="0">
+                <a:solidFill>
+                  <a:srgbClr val="0F172A"/>
+                </a:solidFill>
+                <a:latin typeface="Calibri"/>
+              </a:defRPr>
+            </a:pPr>
+            <a:r>
+              <a:t>- Zero Flaky Tests</a:t>
+            </a:r>
+          </a:p>
+          <a:p>
+            <a:pPr>
+              <a:spcAft>
+                <a:spcPts val="400"/>
+              </a:spcAft>
+              <a:defRPr sz="1100" b="0">
+                <a:solidFill>
+                  <a:srgbClr val="0F172A"/>
+                </a:solidFill>
+                <a:latin typeface="Calibri"/>
+              </a:defRPr>
+            </a:pPr>
+            <a:r>
+              <a:t>- Comprehensive Revert Handling</a:t>
+            </a:r>
+          </a:p>
+          <a:p>
+            <a:pPr>
+              <a:spcAft>
+                <a:spcPts val="400"/>
+              </a:spcAft>
+              <a:defRPr sz="1100" b="0">
+                <a:solidFill>
+                  <a:srgbClr val="0F172A"/>
+                </a:solidFill>
+                <a:latin typeface="Calibri"/>
+              </a:defRPr>
+            </a:pPr>
+            <a:r>
+              <a:t>- Real Local Blockchain Simulation</a:t>
             </a:r>
           </a:p>
         </p:txBody>
@@ -3609,7 +3677,7 @@
           </a:solidFill>
           <a:ln w="12700">
             <a:solidFill>
-              <a:srgbClr val="E2E8F0"/>
+              <a:srgbClr val="CBD5E1"/>
             </a:solidFill>
           </a:ln>
         </p:spPr>
@@ -3665,7 +3733,7 @@
                 <a:solidFill>
                   <a:srgbClr val="0F172A"/>
                 </a:solidFill>
-                <a:latin typeface="Arial"/>
+                <a:latin typeface="Calibri"/>
               </a:defRPr>
             </a:pPr>
             <a:r>
@@ -3677,15 +3745,15 @@
               <a:spcAft>
                 <a:spcPts val="400"/>
               </a:spcAft>
-              <a:defRPr sz="980">
+              <a:defRPr sz="980" b="0">
                 <a:solidFill>
                   <a:srgbClr val="0F172A"/>
                 </a:solidFill>
-                <a:latin typeface="Arial"/>
-              </a:defRPr>
-            </a:pPr>
-            <a:r>
-              <a:t>✔ Registering a certificate on-chain with unique ID and SHA-256 hash</a:t>
+                <a:latin typeface="Calibri"/>
+              </a:defRPr>
+            </a:pPr>
+            <a:r>
+              <a:t>[PASS] Registering a certificate on-chain with unique ID and SHA-256 hash</a:t>
             </a:r>
           </a:p>
           <a:p>
@@ -3693,15 +3761,15 @@
               <a:spcAft>
                 <a:spcPts val="400"/>
               </a:spcAft>
-              <a:defRPr sz="980">
+              <a:defRPr sz="980" b="0">
                 <a:solidFill>
                   <a:srgbClr val="0F172A"/>
                 </a:solidFill>
-                <a:latin typeface="Arial"/>
-              </a:defRPr>
-            </a:pPr>
-            <a:r>
-              <a:t>✔ Rejecting duplicate certificate IDs (preventing record collisions)</a:t>
+                <a:latin typeface="Calibri"/>
+              </a:defRPr>
+            </a:pPr>
+            <a:r>
+              <a:t>[PASS] Rejecting duplicate certificate IDs (preventing record collisions)</a:t>
             </a:r>
           </a:p>
           <a:p>
@@ -3709,15 +3777,15 @@
               <a:spcAft>
                 <a:spcPts val="400"/>
               </a:spcAft>
-              <a:defRPr sz="980">
+              <a:defRPr sz="980" b="0">
                 <a:solidFill>
                   <a:srgbClr val="0F172A"/>
                 </a:solidFill>
-                <a:latin typeface="Arial"/>
-              </a:defRPr>
-            </a:pPr>
-            <a:r>
-              <a:t>✔ Rejecting registration with empty certificate ID or hash parameters</a:t>
+                <a:latin typeface="Calibri"/>
+              </a:defRPr>
+            </a:pPr>
+            <a:r>
+              <a:t>[PASS] Rejecting registration with empty certificate ID or hash parameters</a:t>
             </a:r>
           </a:p>
           <a:p>
@@ -3725,15 +3793,15 @@
               <a:spcAft>
                 <a:spcPts val="400"/>
               </a:spcAft>
-              <a:defRPr sz="980">
+              <a:defRPr sz="980" b="0">
                 <a:solidFill>
                   <a:srgbClr val="0F172A"/>
                 </a:solidFill>
-                <a:latin typeface="Arial"/>
-              </a:defRPr>
-            </a:pPr>
-            <a:r>
-              <a:t>✔ Verifying authentic certificate hashes (returns isValid = true)</a:t>
+                <a:latin typeface="Calibri"/>
+              </a:defRPr>
+            </a:pPr>
+            <a:r>
+              <a:t>[PASS] Verifying authentic certificate hashes (returns isValid = true)</a:t>
             </a:r>
           </a:p>
           <a:p>
@@ -3741,15 +3809,15 @@
               <a:spcAft>
                 <a:spcPts val="400"/>
               </a:spcAft>
-              <a:defRPr sz="980">
+              <a:defRPr sz="980" b="0">
                 <a:solidFill>
                   <a:srgbClr val="0F172A"/>
                 </a:solidFill>
-                <a:latin typeface="Arial"/>
-              </a:defRPr>
-            </a:pPr>
-            <a:r>
-              <a:t>✔ Detecting &amp; rejecting tampered/altered certificate hashes (returns isValid = false)</a:t>
+                <a:latin typeface="Calibri"/>
+              </a:defRPr>
+            </a:pPr>
+            <a:r>
+              <a:t>[PASS] Detecting &amp; rejecting tampered/altered certificate hashes</a:t>
             </a:r>
           </a:p>
           <a:p>
@@ -3757,15 +3825,15 @@
               <a:spcAft>
                 <a:spcPts val="400"/>
               </a:spcAft>
-              <a:defRPr sz="980">
+              <a:defRPr sz="980" b="0">
                 <a:solidFill>
                   <a:srgbClr val="0F172A"/>
                 </a:solidFill>
-                <a:latin typeface="Arial"/>
-              </a:defRPr>
-            </a:pPr>
-            <a:r>
-              <a:t>✔ Graceful handling of non-existent certificate IDs</a:t>
+                <a:latin typeface="Calibri"/>
+              </a:defRPr>
+            </a:pPr>
+            <a:r>
+              <a:t>[PASS] Graceful handling of non-existent certificate IDs</a:t>
             </a:r>
           </a:p>
           <a:p>
@@ -3773,15 +3841,15 @@
               <a:spcAft>
                 <a:spcPts val="400"/>
               </a:spcAft>
-              <a:defRPr sz="980">
+              <a:defRPr sz="980" b="0">
                 <a:solidFill>
                   <a:srgbClr val="0F172A"/>
                 </a:solidFill>
-                <a:latin typeface="Arial"/>
-              </a:defRPr>
-            </a:pPr>
-            <a:r>
-              <a:t>✔ Authorizing certificate revocation by the genuine issuer address</a:t>
+                <a:latin typeface="Calibri"/>
+              </a:defRPr>
+            </a:pPr>
+            <a:r>
+              <a:t>[PASS] Authorizing certificate revocation by genuine issuer address</a:t>
             </a:r>
           </a:p>
           <a:p>
@@ -3789,15 +3857,15 @@
               <a:spcAft>
                 <a:spcPts val="400"/>
               </a:spcAft>
-              <a:defRPr sz="980">
+              <a:defRPr sz="980" b="0">
                 <a:solidFill>
                   <a:srgbClr val="0F172A"/>
                 </a:solidFill>
-                <a:latin typeface="Arial"/>
-              </a:defRPr>
-            </a:pPr>
-            <a:r>
-              <a:t>✔ Rejecting revocation attempts by unauthorized non-issuer accounts</a:t>
+                <a:latin typeface="Calibri"/>
+              </a:defRPr>
+            </a:pPr>
+            <a:r>
+              <a:t>[PASS] Rejecting revocation attempts by unauthorized non-issuer accounts</a:t>
             </a:r>
           </a:p>
           <a:p>
@@ -3805,15 +3873,15 @@
               <a:spcAft>
                 <a:spcPts val="400"/>
               </a:spcAft>
-              <a:defRPr sz="980">
+              <a:defRPr sz="980" b="0">
                 <a:solidFill>
                   <a:srgbClr val="0F172A"/>
                 </a:solidFill>
-                <a:latin typeface="Arial"/>
-              </a:defRPr>
-            </a:pPr>
-            <a:r>
-              <a:t>✔ Rejecting verification for revoked certificates (isRevoked = true)</a:t>
+                <a:latin typeface="Calibri"/>
+              </a:defRPr>
+            </a:pPr>
+            <a:r>
+              <a:t>[PASS] Rejecting verification for revoked certificates (isRevoked = true)</a:t>
             </a:r>
           </a:p>
           <a:p>
@@ -3821,15 +3889,15 @@
               <a:spcAft>
                 <a:spcPts val="400"/>
               </a:spcAft>
-              <a:defRPr sz="980">
+              <a:defRPr sz="980" b="0">
                 <a:solidFill>
                   <a:srgbClr val="0F172A"/>
                 </a:solidFill>
-                <a:latin typeface="Arial"/>
-              </a:defRPr>
-            </a:pPr>
-            <a:r>
-              <a:t>✔ Preventing duplicate revocation attempts on already revoked certificates</a:t>
+                <a:latin typeface="Calibri"/>
+              </a:defRPr>
+            </a:pPr>
+            <a:r>
+              <a:t>[PASS] Preventing duplicate revocation attempts on revoked certificates</a:t>
             </a:r>
           </a:p>
         </p:txBody>
@@ -3870,7 +3938,9 @@
             <a:srgbClr val="0F172A"/>
           </a:solidFill>
           <a:ln>
-            <a:noFill/>
+            <a:solidFill>
+              <a:srgbClr val="0F172A"/>
+            </a:solidFill>
           </a:ln>
         </p:spPr>
         <p:style>
@@ -3918,11 +3988,14 @@
           <a:lstStyle/>
           <a:p>
             <a:pPr>
+              <a:spcAft>
+                <a:spcPts val="400"/>
+              </a:spcAft>
               <a:defRPr sz="950" b="1">
                 <a:solidFill>
                   <a:srgbClr val="60A5FA"/>
                 </a:solidFill>
-                <a:latin typeface="Arial"/>
+                <a:latin typeface="Calibri"/>
               </a:defRPr>
             </a:pPr>
             <a:r>
@@ -3954,11 +4027,14 @@
           <a:lstStyle/>
           <a:p>
             <a:pPr>
+              <a:spcAft>
+                <a:spcPts val="400"/>
+              </a:spcAft>
               <a:defRPr sz="2000" b="1">
                 <a:solidFill>
                   <a:srgbClr val="FFFFFF"/>
                 </a:solidFill>
-                <a:latin typeface="Arial"/>
+                <a:latin typeface="Calibri"/>
               </a:defRPr>
             </a:pPr>
             <a:r>
@@ -3985,7 +4061,9 @@
             <a:srgbClr val="2563EB"/>
           </a:solidFill>
           <a:ln>
-            <a:noFill/>
+            <a:solidFill>
+              <a:srgbClr val="2563EB"/>
+            </a:solidFill>
           </a:ln>
         </p:spPr>
         <p:style>
@@ -4029,7 +4107,7 @@
           </a:solidFill>
           <a:ln w="12700">
             <a:solidFill>
-              <a:srgbClr val="E2E8F0"/>
+              <a:srgbClr val="CBD5E1"/>
             </a:solidFill>
           </a:ln>
         </p:spPr>
@@ -4085,7 +4163,7 @@
                 <a:solidFill>
                   <a:srgbClr val="2563EB"/>
                 </a:solidFill>
-                <a:latin typeface="Arial"/>
+                <a:latin typeface="Calibri"/>
               </a:defRPr>
             </a:pPr>
             <a:r>
@@ -4094,11 +4172,14 @@
           </a:p>
           <a:p>
             <a:pPr>
-              <a:defRPr sz="1100">
+              <a:spcAft>
+                <a:spcPts val="400"/>
+              </a:spcAft>
+              <a:defRPr sz="1100" b="0">
                 <a:solidFill>
                   <a:srgbClr val="0F172A"/>
                 </a:solidFill>
-                <a:latin typeface="Arial"/>
+                <a:latin typeface="Calibri"/>
               </a:defRPr>
             </a:pPr>
             <a:r>
@@ -4126,7 +4207,7 @@
           </a:solidFill>
           <a:ln w="12700">
             <a:solidFill>
-              <a:srgbClr val="E2E8F0"/>
+              <a:srgbClr val="CBD5E1"/>
             </a:solidFill>
           </a:ln>
         </p:spPr>
@@ -4182,7 +4263,7 @@
                 <a:solidFill>
                   <a:srgbClr val="2563EB"/>
                 </a:solidFill>
-                <a:latin typeface="Arial"/>
+                <a:latin typeface="Calibri"/>
               </a:defRPr>
             </a:pPr>
             <a:r>
@@ -4191,11 +4272,14 @@
           </a:p>
           <a:p>
             <a:pPr>
-              <a:defRPr sz="1100">
+              <a:spcAft>
+                <a:spcPts val="400"/>
+              </a:spcAft>
+              <a:defRPr sz="1100" b="0">
                 <a:solidFill>
                   <a:srgbClr val="0F172A"/>
                 </a:solidFill>
-                <a:latin typeface="Arial"/>
+                <a:latin typeface="Calibri"/>
               </a:defRPr>
             </a:pPr>
             <a:r>
@@ -4223,7 +4307,7 @@
           </a:solidFill>
           <a:ln w="12700">
             <a:solidFill>
-              <a:srgbClr val="E2E8F0"/>
+              <a:srgbClr val="CBD5E1"/>
             </a:solidFill>
           </a:ln>
         </p:spPr>
@@ -4279,7 +4363,7 @@
                 <a:solidFill>
                   <a:srgbClr val="2563EB"/>
                 </a:solidFill>
-                <a:latin typeface="Arial"/>
+                <a:latin typeface="Calibri"/>
               </a:defRPr>
             </a:pPr>
             <a:r>
@@ -4288,11 +4372,14 @@
           </a:p>
           <a:p>
             <a:pPr>
-              <a:defRPr sz="1100">
+              <a:spcAft>
+                <a:spcPts val="400"/>
+              </a:spcAft>
+              <a:defRPr sz="1100" b="0">
                 <a:solidFill>
                   <a:srgbClr val="0F172A"/>
                 </a:solidFill>
-                <a:latin typeface="Arial"/>
+                <a:latin typeface="Calibri"/>
               </a:defRPr>
             </a:pPr>
             <a:r>
@@ -4320,7 +4407,7 @@
           </a:solidFill>
           <a:ln w="12700">
             <a:solidFill>
-              <a:srgbClr val="E2E8F0"/>
+              <a:srgbClr val="CBD5E1"/>
             </a:solidFill>
           </a:ln>
         </p:spPr>
@@ -4376,7 +4463,7 @@
                 <a:solidFill>
                   <a:srgbClr val="2563EB"/>
                 </a:solidFill>
-                <a:latin typeface="Arial"/>
+                <a:latin typeface="Calibri"/>
               </a:defRPr>
             </a:pPr>
             <a:r>
@@ -4385,11 +4472,14 @@
           </a:p>
           <a:p>
             <a:pPr>
-              <a:defRPr sz="1100">
+              <a:spcAft>
+                <a:spcPts val="400"/>
+              </a:spcAft>
+              <a:defRPr sz="1100" b="0">
                 <a:solidFill>
                   <a:srgbClr val="0F172A"/>
                 </a:solidFill>
-                <a:latin typeface="Arial"/>
+                <a:latin typeface="Calibri"/>
               </a:defRPr>
             </a:pPr>
             <a:r>
@@ -4434,7 +4524,9 @@
             <a:srgbClr val="0F172A"/>
           </a:solidFill>
           <a:ln>
-            <a:noFill/>
+            <a:solidFill>
+              <a:srgbClr val="0F172A"/>
+            </a:solidFill>
           </a:ln>
         </p:spPr>
         <p:style>
@@ -4489,7 +4581,7 @@
                 <a:solidFill>
                   <a:srgbClr val="FFFFFF"/>
                 </a:solidFill>
-                <a:latin typeface="Arial"/>
+                <a:latin typeface="Calibri"/>
               </a:defRPr>
             </a:pPr>
             <a:r>
@@ -4505,7 +4597,7 @@
                 <a:solidFill>
                   <a:srgbClr val="60A5FA"/>
                 </a:solidFill>
-                <a:latin typeface="Arial"/>
+                <a:latin typeface="Calibri"/>
               </a:defRPr>
             </a:pPr>
             <a:r>
@@ -4514,17 +4606,32 @@
           </a:p>
           <a:p>
             <a:pPr>
-              <a:defRPr sz="1300">
+              <a:spcAft>
+                <a:spcPts val="400"/>
+              </a:spcAft>
+              <a:defRPr sz="1300" b="0">
                 <a:solidFill>
                   <a:srgbClr val="CBD5E1"/>
                 </a:solidFill>
-                <a:latin typeface="Arial"/>
+                <a:latin typeface="Calibri"/>
               </a:defRPr>
             </a:pPr>
             <a:r>
               <a:t>GitHub Repository: https://github.com/saksham1126/SkillChain</a:t>
             </a:r>
-            <a:br/>
+          </a:p>
+          <a:p>
+            <a:pPr>
+              <a:spcAft>
+                <a:spcPts val="400"/>
+              </a:spcAft>
+              <a:defRPr sz="1300" b="0">
+                <a:solidFill>
+                  <a:srgbClr val="CBD5E1"/>
+                </a:solidFill>
+                <a:latin typeface="Calibri"/>
+              </a:defRPr>
+            </a:pPr>
             <a:r>
               <a:t>Author: Saksham Pathak  |  Project: SkillChain — Blockchain-Based Skill Passport</a:t>
             </a:r>
@@ -4567,7 +4674,9 @@
             <a:srgbClr val="0F172A"/>
           </a:solidFill>
           <a:ln>
-            <a:noFill/>
+            <a:solidFill>
+              <a:srgbClr val="0F172A"/>
+            </a:solidFill>
           </a:ln>
         </p:spPr>
         <p:style>
@@ -4615,11 +4724,14 @@
           <a:lstStyle/>
           <a:p>
             <a:pPr>
+              <a:spcAft>
+                <a:spcPts val="400"/>
+              </a:spcAft>
               <a:defRPr sz="950" b="1">
                 <a:solidFill>
                   <a:srgbClr val="60A5FA"/>
                 </a:solidFill>
-                <a:latin typeface="Arial"/>
+                <a:latin typeface="Calibri"/>
               </a:defRPr>
             </a:pPr>
             <a:r>
@@ -4651,11 +4763,14 @@
           <a:lstStyle/>
           <a:p>
             <a:pPr>
+              <a:spcAft>
+                <a:spcPts val="400"/>
+              </a:spcAft>
               <a:defRPr sz="2000" b="1">
                 <a:solidFill>
                   <a:srgbClr val="FFFFFF"/>
                 </a:solidFill>
-                <a:latin typeface="Arial"/>
+                <a:latin typeface="Calibri"/>
               </a:defRPr>
             </a:pPr>
             <a:r>
@@ -4682,7 +4797,9 @@
             <a:srgbClr val="2563EB"/>
           </a:solidFill>
           <a:ln>
-            <a:noFill/>
+            <a:solidFill>
+              <a:srgbClr val="2563EB"/>
+            </a:solidFill>
           </a:ln>
         </p:spPr>
         <p:style>
@@ -4726,7 +4843,7 @@
           </a:solidFill>
           <a:ln w="12700">
             <a:solidFill>
-              <a:srgbClr val="E2E8F0"/>
+              <a:srgbClr val="CBD5E1"/>
             </a:solidFill>
           </a:ln>
         </p:spPr>
@@ -4782,7 +4899,7 @@
                 <a:solidFill>
                   <a:srgbClr val="0F172A"/>
                 </a:solidFill>
-                <a:latin typeface="Arial"/>
+                <a:latin typeface="Calibri"/>
               </a:defRPr>
             </a:pPr>
             <a:r>
@@ -4794,15 +4911,15 @@
               <a:spcAft>
                 <a:spcPts val="1000"/>
               </a:spcAft>
-              <a:defRPr sz="1150">
+              <a:defRPr sz="1150" b="0">
                 <a:solidFill>
                   <a:srgbClr val="0F172A"/>
                 </a:solidFill>
-                <a:latin typeface="Arial"/>
-              </a:defRPr>
-            </a:pPr>
-            <a:r>
-              <a:t>• Degrees, diplomas, and certifications are foundational for employment and admissions.</a:t>
+                <a:latin typeface="Calibri"/>
+              </a:defRPr>
+            </a:pPr>
+            <a:r>
+              <a:t>- Degrees, diplomas, and certifications are foundational for employment and admissions.</a:t>
             </a:r>
           </a:p>
           <a:p>
@@ -4810,15 +4927,15 @@
               <a:spcAft>
                 <a:spcPts val="1000"/>
               </a:spcAft>
-              <a:defRPr sz="1150">
+              <a:defRPr sz="1150" b="0">
                 <a:solidFill>
                   <a:srgbClr val="0F172A"/>
                 </a:solidFill>
-                <a:latin typeface="Arial"/>
-              </a:defRPr>
-            </a:pPr>
-            <a:r>
-              <a:t>• Traditional paper documents and static digital PDFs are exceptionally easy to forge.</a:t>
+                <a:latin typeface="Calibri"/>
+              </a:defRPr>
+            </a:pPr>
+            <a:r>
+              <a:t>- Traditional paper documents and static digital PDFs are exceptionally easy to forge.</a:t>
             </a:r>
           </a:p>
           <a:p>
@@ -4826,15 +4943,15 @@
               <a:spcAft>
                 <a:spcPts val="1000"/>
               </a:spcAft>
-              <a:defRPr sz="1150">
+              <a:defRPr sz="1150" b="0">
                 <a:solidFill>
                   <a:srgbClr val="0F172A"/>
                 </a:solidFill>
-                <a:latin typeface="Arial"/>
-              </a:defRPr>
-            </a:pPr>
-            <a:r>
-              <a:t>• Over 30% of resumes contain modified or embellished educational and skill claims.</a:t>
+                <a:latin typeface="Calibri"/>
+              </a:defRPr>
+            </a:pPr>
+            <a:r>
+              <a:t>- Over 30% of resumes contain modified or embellished educational and skill claims.</a:t>
             </a:r>
           </a:p>
           <a:p>
@@ -4842,15 +4959,15 @@
               <a:spcAft>
                 <a:spcPts val="1000"/>
               </a:spcAft>
-              <a:defRPr sz="1150">
+              <a:defRPr sz="1150" b="0">
                 <a:solidFill>
                   <a:srgbClr val="0F172A"/>
                 </a:solidFill>
-                <a:latin typeface="Arial"/>
-              </a:defRPr>
-            </a:pPr>
-            <a:r>
-              <a:t>• Credential fraud has become a multi-billion dollar worldwide challenge.</a:t>
+                <a:latin typeface="Calibri"/>
+              </a:defRPr>
+            </a:pPr>
+            <a:r>
+              <a:t>- Credential fraud has become a multi-billion dollar worldwide challenge.</a:t>
             </a:r>
           </a:p>
         </p:txBody>
@@ -4874,7 +4991,7 @@
           </a:solidFill>
           <a:ln w="12700">
             <a:solidFill>
-              <a:srgbClr val="E2E8F0"/>
+              <a:srgbClr val="CBD5E1"/>
             </a:solidFill>
           </a:ln>
         </p:spPr>
@@ -4930,7 +5047,7 @@
                 <a:solidFill>
                   <a:srgbClr val="0F172A"/>
                 </a:solidFill>
-                <a:latin typeface="Arial"/>
+                <a:latin typeface="Calibri"/>
               </a:defRPr>
             </a:pPr>
             <a:r>
@@ -4942,15 +5059,15 @@
               <a:spcAft>
                 <a:spcPts val="1000"/>
               </a:spcAft>
-              <a:defRPr sz="1150">
+              <a:defRPr sz="1150" b="0">
                 <a:solidFill>
                   <a:srgbClr val="0F172A"/>
                 </a:solidFill>
-                <a:latin typeface="Arial"/>
-              </a:defRPr>
-            </a:pPr>
-            <a:r>
-              <a:t>• Verification currently requires contacting registrar offices or proprietary portals.</a:t>
+                <a:latin typeface="Calibri"/>
+              </a:defRPr>
+            </a:pPr>
+            <a:r>
+              <a:t>- Verification currently requires contacting registrar offices or proprietary portals.</a:t>
             </a:r>
           </a:p>
           <a:p>
@@ -4958,15 +5075,15 @@
               <a:spcAft>
                 <a:spcPts val="1000"/>
               </a:spcAft>
-              <a:defRPr sz="1150">
+              <a:defRPr sz="1150" b="0">
                 <a:solidFill>
                   <a:srgbClr val="0F172A"/>
                 </a:solidFill>
-                <a:latin typeface="Arial"/>
-              </a:defRPr>
-            </a:pPr>
-            <a:r>
-              <a:t>• Centralized databases represent single points of failure vulnerable to cyberattacks.</a:t>
+                <a:latin typeface="Calibri"/>
+              </a:defRPr>
+            </a:pPr>
+            <a:r>
+              <a:t>- Centralized databases represent single points of failure vulnerable to cyberattacks.</a:t>
             </a:r>
           </a:p>
           <a:p>
@@ -4974,15 +5091,15 @@
               <a:spcAft>
                 <a:spcPts val="1000"/>
               </a:spcAft>
-              <a:defRPr sz="1150">
+              <a:defRPr sz="1150" b="0">
                 <a:solidFill>
                   <a:srgbClr val="0F172A"/>
                 </a:solidFill>
-                <a:latin typeface="Arial"/>
-              </a:defRPr>
-            </a:pPr>
-            <a:r>
-              <a:t>• Manual background checks take between 5 to 20 business days to complete.</a:t>
+                <a:latin typeface="Calibri"/>
+              </a:defRPr>
+            </a:pPr>
+            <a:r>
+              <a:t>- Manual background checks take between 5 to 20 business days to complete.</a:t>
             </a:r>
           </a:p>
           <a:p>
@@ -4990,15 +5107,15 @@
               <a:spcAft>
                 <a:spcPts val="1000"/>
               </a:spcAft>
-              <a:defRPr sz="1150">
+              <a:defRPr sz="1150" b="0">
                 <a:solidFill>
                   <a:srgbClr val="0F172A"/>
                 </a:solidFill>
-                <a:latin typeface="Arial"/>
-              </a:defRPr>
-            </a:pPr>
-            <a:r>
-              <a:t>• High administrative costs for universities and candidate screening agencies.</a:t>
+                <a:latin typeface="Calibri"/>
+              </a:defRPr>
+            </a:pPr>
+            <a:r>
+              <a:t>- High administrative costs for universities and candidate screening agencies.</a:t>
             </a:r>
           </a:p>
         </p:txBody>
@@ -5078,7 +5195,7 @@
                 <a:solidFill>
                   <a:srgbClr val="2563EB"/>
                 </a:solidFill>
-                <a:latin typeface="Arial"/>
+                <a:latin typeface="Calibri"/>
               </a:defRPr>
             </a:pPr>
             <a:r>
@@ -5090,15 +5207,15 @@
               <a:spcAft>
                 <a:spcPts val="1000"/>
               </a:spcAft>
-              <a:defRPr sz="1150">
+              <a:defRPr sz="1150" b="0">
                 <a:solidFill>
                   <a:srgbClr val="0F172A"/>
                 </a:solidFill>
-                <a:latin typeface="Arial"/>
-              </a:defRPr>
-            </a:pPr>
-            <a:r>
-              <a:t>✔ Blockchain delivers an immutable, decentralized ledger immune to unilateral tampering.</a:t>
+                <a:latin typeface="Calibri"/>
+              </a:defRPr>
+            </a:pPr>
+            <a:r>
+              <a:t>[+] Blockchain delivers an immutable, decentralized ledger immune to unilateral tampering.</a:t>
             </a:r>
           </a:p>
           <a:p>
@@ -5106,15 +5223,15 @@
               <a:spcAft>
                 <a:spcPts val="1000"/>
               </a:spcAft>
-              <a:defRPr sz="1150">
+              <a:defRPr sz="1150" b="0">
                 <a:solidFill>
                   <a:srgbClr val="0F172A"/>
                 </a:solidFill>
-                <a:latin typeface="Arial"/>
-              </a:defRPr>
-            </a:pPr>
-            <a:r>
-              <a:t>✔ Smart contracts enforce deterministic verification rules without human bias.</a:t>
+                <a:latin typeface="Calibri"/>
+              </a:defRPr>
+            </a:pPr>
+            <a:r>
+              <a:t>[+] Smart contracts enforce deterministic verification rules without human bias.</a:t>
             </a:r>
           </a:p>
           <a:p>
@@ -5122,15 +5239,15 @@
               <a:spcAft>
                 <a:spcPts val="1000"/>
               </a:spcAft>
-              <a:defRPr sz="1150">
+              <a:defRPr sz="1150" b="0">
                 <a:solidFill>
                   <a:srgbClr val="0F172A"/>
                 </a:solidFill>
-                <a:latin typeface="Arial"/>
-              </a:defRPr>
-            </a:pPr>
-            <a:r>
-              <a:t>✔ Public zero-trust verification: Anyone can authenticate credentials in milliseconds.</a:t>
+                <a:latin typeface="Calibri"/>
+              </a:defRPr>
+            </a:pPr>
+            <a:r>
+              <a:t>[+] Public zero-trust verification: Anyone can authenticate credentials in milliseconds.</a:t>
             </a:r>
           </a:p>
           <a:p>
@@ -5138,15 +5255,15 @@
               <a:spcAft>
                 <a:spcPts val="1000"/>
               </a:spcAft>
-              <a:defRPr sz="1150">
+              <a:defRPr sz="1150" b="0">
                 <a:solidFill>
                   <a:srgbClr val="0F172A"/>
                 </a:solidFill>
-                <a:latin typeface="Arial"/>
-              </a:defRPr>
-            </a:pPr>
-            <a:r>
-              <a:t>✔ Cryptographic hashing protects student personal privacy while proving authenticity.</a:t>
+                <a:latin typeface="Calibri"/>
+              </a:defRPr>
+            </a:pPr>
+            <a:r>
+              <a:t>[+] Cryptographic hashing protects student personal privacy while proving authenticity.</a:t>
             </a:r>
           </a:p>
         </p:txBody>
@@ -5187,7 +5304,9 @@
             <a:srgbClr val="0F172A"/>
           </a:solidFill>
           <a:ln>
-            <a:noFill/>
+            <a:solidFill>
+              <a:srgbClr val="0F172A"/>
+            </a:solidFill>
           </a:ln>
         </p:spPr>
         <p:style>
@@ -5235,11 +5354,14 @@
           <a:lstStyle/>
           <a:p>
             <a:pPr>
+              <a:spcAft>
+                <a:spcPts val="400"/>
+              </a:spcAft>
               <a:defRPr sz="950" b="1">
                 <a:solidFill>
                   <a:srgbClr val="60A5FA"/>
                 </a:solidFill>
-                <a:latin typeface="Arial"/>
+                <a:latin typeface="Calibri"/>
               </a:defRPr>
             </a:pPr>
             <a:r>
@@ -5271,11 +5393,14 @@
           <a:lstStyle/>
           <a:p>
             <a:pPr>
+              <a:spcAft>
+                <a:spcPts val="400"/>
+              </a:spcAft>
               <a:defRPr sz="2000" b="1">
                 <a:solidFill>
                   <a:srgbClr val="FFFFFF"/>
                 </a:solidFill>
-                <a:latin typeface="Arial"/>
+                <a:latin typeface="Calibri"/>
               </a:defRPr>
             </a:pPr>
             <a:r>
@@ -5302,7 +5427,9 @@
             <a:srgbClr val="2563EB"/>
           </a:solidFill>
           <a:ln>
-            <a:noFill/>
+            <a:solidFill>
+              <a:srgbClr val="2563EB"/>
+            </a:solidFill>
           </a:ln>
         </p:spPr>
         <p:style>
@@ -5346,7 +5473,7 @@
           </a:solidFill>
           <a:ln w="12700">
             <a:solidFill>
-              <a:srgbClr val="E2E8F0"/>
+              <a:srgbClr val="CBD5E1"/>
             </a:solidFill>
           </a:ln>
         </p:spPr>
@@ -5402,7 +5529,7 @@
                 <a:solidFill>
                   <a:srgbClr val="2563EB"/>
                 </a:solidFill>
-                <a:latin typeface="Arial"/>
+                <a:latin typeface="Calibri"/>
               </a:defRPr>
             </a:pPr>
             <a:r>
@@ -5411,11 +5538,14 @@
           </a:p>
           <a:p>
             <a:pPr>
-              <a:defRPr sz="1100">
+              <a:spcAft>
+                <a:spcPts val="400"/>
+              </a:spcAft>
+              <a:defRPr sz="1100" b="0">
                 <a:solidFill>
                   <a:srgbClr val="0F172A"/>
                 </a:solidFill>
-                <a:latin typeface="Arial"/>
+                <a:latin typeface="Calibri"/>
               </a:defRPr>
             </a:pPr>
             <a:r>
@@ -5443,7 +5573,7 @@
           </a:solidFill>
           <a:ln w="12700">
             <a:solidFill>
-              <a:srgbClr val="E2E8F0"/>
+              <a:srgbClr val="CBD5E1"/>
             </a:solidFill>
           </a:ln>
         </p:spPr>
@@ -5499,7 +5629,7 @@
                 <a:solidFill>
                   <a:srgbClr val="2563EB"/>
                 </a:solidFill>
-                <a:latin typeface="Arial"/>
+                <a:latin typeface="Calibri"/>
               </a:defRPr>
             </a:pPr>
             <a:r>
@@ -5508,11 +5638,14 @@
           </a:p>
           <a:p>
             <a:pPr>
-              <a:defRPr sz="1100">
+              <a:spcAft>
+                <a:spcPts val="400"/>
+              </a:spcAft>
+              <a:defRPr sz="1100" b="0">
                 <a:solidFill>
                   <a:srgbClr val="0F172A"/>
                 </a:solidFill>
-                <a:latin typeface="Arial"/>
+                <a:latin typeface="Calibri"/>
               </a:defRPr>
             </a:pPr>
             <a:r>
@@ -5540,7 +5673,7 @@
           </a:solidFill>
           <a:ln w="12700">
             <a:solidFill>
-              <a:srgbClr val="E2E8F0"/>
+              <a:srgbClr val="CBD5E1"/>
             </a:solidFill>
           </a:ln>
         </p:spPr>
@@ -5596,7 +5729,7 @@
                 <a:solidFill>
                   <a:srgbClr val="2563EB"/>
                 </a:solidFill>
-                <a:latin typeface="Arial"/>
+                <a:latin typeface="Calibri"/>
               </a:defRPr>
             </a:pPr>
             <a:r>
@@ -5605,11 +5738,14 @@
           </a:p>
           <a:p>
             <a:pPr>
-              <a:defRPr sz="1100">
+              <a:spcAft>
+                <a:spcPts val="400"/>
+              </a:spcAft>
+              <a:defRPr sz="1100" b="0">
                 <a:solidFill>
                   <a:srgbClr val="0F172A"/>
                 </a:solidFill>
-                <a:latin typeface="Arial"/>
+                <a:latin typeface="Calibri"/>
               </a:defRPr>
             </a:pPr>
             <a:r>
@@ -5637,7 +5773,7 @@
           </a:solidFill>
           <a:ln w="12700">
             <a:solidFill>
-              <a:srgbClr val="E2E8F0"/>
+              <a:srgbClr val="CBD5E1"/>
             </a:solidFill>
           </a:ln>
         </p:spPr>
@@ -5693,7 +5829,7 @@
                 <a:solidFill>
                   <a:srgbClr val="2563EB"/>
                 </a:solidFill>
-                <a:latin typeface="Arial"/>
+                <a:latin typeface="Calibri"/>
               </a:defRPr>
             </a:pPr>
             <a:r>
@@ -5702,11 +5838,14 @@
           </a:p>
           <a:p>
             <a:pPr>
-              <a:defRPr sz="1100">
+              <a:spcAft>
+                <a:spcPts val="400"/>
+              </a:spcAft>
+              <a:defRPr sz="1100" b="0">
                 <a:solidFill>
                   <a:srgbClr val="0F172A"/>
                 </a:solidFill>
-                <a:latin typeface="Arial"/>
+                <a:latin typeface="Calibri"/>
               </a:defRPr>
             </a:pPr>
             <a:r>
@@ -5751,7 +5890,9 @@
             <a:srgbClr val="0F172A"/>
           </a:solidFill>
           <a:ln>
-            <a:noFill/>
+            <a:solidFill>
+              <a:srgbClr val="0F172A"/>
+            </a:solidFill>
           </a:ln>
         </p:spPr>
         <p:style>
@@ -5799,11 +5940,14 @@
           <a:lstStyle/>
           <a:p>
             <a:pPr>
+              <a:spcAft>
+                <a:spcPts val="400"/>
+              </a:spcAft>
               <a:defRPr sz="950" b="1">
                 <a:solidFill>
                   <a:srgbClr val="60A5FA"/>
                 </a:solidFill>
-                <a:latin typeface="Arial"/>
+                <a:latin typeface="Calibri"/>
               </a:defRPr>
             </a:pPr>
             <a:r>
@@ -5835,11 +5979,14 @@
           <a:lstStyle/>
           <a:p>
             <a:pPr>
+              <a:spcAft>
+                <a:spcPts val="400"/>
+              </a:spcAft>
               <a:defRPr sz="2000" b="1">
                 <a:solidFill>
                   <a:srgbClr val="FFFFFF"/>
                 </a:solidFill>
-                <a:latin typeface="Arial"/>
+                <a:latin typeface="Calibri"/>
               </a:defRPr>
             </a:pPr>
             <a:r>
@@ -5866,7 +6013,9 @@
             <a:srgbClr val="2563EB"/>
           </a:solidFill>
           <a:ln>
-            <a:noFill/>
+            <a:solidFill>
+              <a:srgbClr val="2563EB"/>
+            </a:solidFill>
           </a:ln>
         </p:spPr>
         <p:style>
@@ -5910,7 +6059,7 @@
           </a:solidFill>
           <a:ln w="12700">
             <a:solidFill>
-              <a:srgbClr val="E2E8F0"/>
+              <a:srgbClr val="0F172A"/>
             </a:solidFill>
           </a:ln>
         </p:spPr>
@@ -5966,7 +6115,7 @@
                 <a:solidFill>
                   <a:srgbClr val="FFFFFF"/>
                 </a:solidFill>
-                <a:latin typeface="Arial"/>
+                <a:latin typeface="Calibri"/>
               </a:defRPr>
             </a:pPr>
             <a:r>
@@ -5982,7 +6131,7 @@
                 <a:solidFill>
                   <a:srgbClr val="60A5FA"/>
                 </a:solidFill>
-                <a:latin typeface="Arial"/>
+                <a:latin typeface="Calibri"/>
               </a:defRPr>
             </a:pPr>
             <a:r>
@@ -5991,18 +6140,32 @@
           </a:p>
           <a:p>
             <a:pPr>
-              <a:defRPr sz="1200">
+              <a:spcAft>
+                <a:spcPts val="1000"/>
+              </a:spcAft>
+              <a:defRPr sz="1200" b="0">
                 <a:solidFill>
                   <a:srgbClr val="E2E8F0"/>
                 </a:solidFill>
-                <a:latin typeface="Arial"/>
+                <a:latin typeface="Calibri"/>
               </a:defRPr>
             </a:pPr>
             <a:r>
               <a:t>SkillChain is a decentralized skill passport where institutions anchor tamper-proof cryptographic proofs (SHA-256 digests) into Ethereum smart contracts.</a:t>
             </a:r>
-            <a:br/>
-            <a:br/>
+          </a:p>
+          <a:p>
+            <a:pPr>
+              <a:spcAft>
+                <a:spcPts val="400"/>
+              </a:spcAft>
+              <a:defRPr sz="1200" b="0">
+                <a:solidFill>
+                  <a:srgbClr val="E2E8F0"/>
+                </a:solidFill>
+                <a:latin typeface="Calibri"/>
+              </a:defRPr>
+            </a:pPr>
             <a:r>
               <a:t>Sensitive student records remain off-chain for privacy, while the blockchain guarantees zero-trust immutability and instant public verification.</a:t>
             </a:r>
@@ -6028,7 +6191,7 @@
           </a:solidFill>
           <a:ln w="12700">
             <a:solidFill>
-              <a:srgbClr val="E2E8F0"/>
+              <a:srgbClr val="CBD5E1"/>
             </a:solidFill>
           </a:ln>
         </p:spPr>
@@ -6063,7 +6226,7 @@
         <p:spPr>
           <a:xfrm>
             <a:off x="5577840" y="1627632"/>
-            <a:ext cx="5669280" cy="1088136"/>
+            <a:ext cx="5669280" cy="1097280"/>
           </a:xfrm>
           <a:prstGeom prst="rect">
             <a:avLst/>
@@ -6084,7 +6247,7 @@
                 <a:solidFill>
                   <a:srgbClr val="2563EB"/>
                 </a:solidFill>
-                <a:latin typeface="Arial"/>
+                <a:latin typeface="Calibri"/>
               </a:defRPr>
             </a:pPr>
             <a:r>
@@ -6093,11 +6256,14 @@
           </a:p>
           <a:p>
             <a:pPr>
-              <a:defRPr sz="1050">
+              <a:spcAft>
+                <a:spcPts val="400"/>
+              </a:spcAft>
+              <a:defRPr sz="1050" b="0">
                 <a:solidFill>
                   <a:srgbClr val="0F172A"/>
                 </a:solidFill>
-                <a:latin typeface="Arial"/>
+                <a:latin typeface="Calibri"/>
               </a:defRPr>
             </a:pPr>
             <a:r>
@@ -6125,7 +6291,7 @@
           </a:solidFill>
           <a:ln w="12700">
             <a:solidFill>
-              <a:srgbClr val="E2E8F0"/>
+              <a:srgbClr val="CBD5E1"/>
             </a:solidFill>
           </a:ln>
         </p:spPr>
@@ -6160,7 +6326,7 @@
         <p:spPr>
           <a:xfrm>
             <a:off x="5577840" y="3273552"/>
-            <a:ext cx="5669280" cy="1088136"/>
+            <a:ext cx="5669280" cy="1097280"/>
           </a:xfrm>
           <a:prstGeom prst="rect">
             <a:avLst/>
@@ -6181,7 +6347,7 @@
                 <a:solidFill>
                   <a:srgbClr val="2563EB"/>
                 </a:solidFill>
-                <a:latin typeface="Arial"/>
+                <a:latin typeface="Calibri"/>
               </a:defRPr>
             </a:pPr>
             <a:r>
@@ -6190,11 +6356,14 @@
           </a:p>
           <a:p>
             <a:pPr>
-              <a:defRPr sz="1050">
+              <a:spcAft>
+                <a:spcPts val="400"/>
+              </a:spcAft>
+              <a:defRPr sz="1050" b="0">
                 <a:solidFill>
                   <a:srgbClr val="0F172A"/>
                 </a:solidFill>
-                <a:latin typeface="Arial"/>
+                <a:latin typeface="Calibri"/>
               </a:defRPr>
             </a:pPr>
             <a:r>
@@ -6222,7 +6391,7 @@
           </a:solidFill>
           <a:ln w="12700">
             <a:solidFill>
-              <a:srgbClr val="E2E8F0"/>
+              <a:srgbClr val="CBD5E1"/>
             </a:solidFill>
           </a:ln>
         </p:spPr>
@@ -6257,7 +6426,7 @@
         <p:spPr>
           <a:xfrm>
             <a:off x="5577840" y="4919472"/>
-            <a:ext cx="5669280" cy="1088136"/>
+            <a:ext cx="5669280" cy="1097280"/>
           </a:xfrm>
           <a:prstGeom prst="rect">
             <a:avLst/>
@@ -6278,7 +6447,7 @@
                 <a:solidFill>
                   <a:srgbClr val="2563EB"/>
                 </a:solidFill>
-                <a:latin typeface="Arial"/>
+                <a:latin typeface="Calibri"/>
               </a:defRPr>
             </a:pPr>
             <a:r>
@@ -6287,11 +6456,14 @@
           </a:p>
           <a:p>
             <a:pPr>
-              <a:defRPr sz="1050">
+              <a:spcAft>
+                <a:spcPts val="400"/>
+              </a:spcAft>
+              <a:defRPr sz="1050" b="0">
                 <a:solidFill>
                   <a:srgbClr val="0F172A"/>
                 </a:solidFill>
-                <a:latin typeface="Arial"/>
+                <a:latin typeface="Calibri"/>
               </a:defRPr>
             </a:pPr>
             <a:r>
@@ -6336,7 +6508,9 @@
             <a:srgbClr val="0F172A"/>
           </a:solidFill>
           <a:ln>
-            <a:noFill/>
+            <a:solidFill>
+              <a:srgbClr val="0F172A"/>
+            </a:solidFill>
           </a:ln>
         </p:spPr>
         <p:style>
@@ -6384,11 +6558,14 @@
           <a:lstStyle/>
           <a:p>
             <a:pPr>
+              <a:spcAft>
+                <a:spcPts val="400"/>
+              </a:spcAft>
               <a:defRPr sz="950" b="1">
                 <a:solidFill>
                   <a:srgbClr val="60A5FA"/>
                 </a:solidFill>
-                <a:latin typeface="Arial"/>
+                <a:latin typeface="Calibri"/>
               </a:defRPr>
             </a:pPr>
             <a:r>
@@ -6420,11 +6597,14 @@
           <a:lstStyle/>
           <a:p>
             <a:pPr>
+              <a:spcAft>
+                <a:spcPts val="400"/>
+              </a:spcAft>
               <a:defRPr sz="2000" b="1">
                 <a:solidFill>
                   <a:srgbClr val="FFFFFF"/>
                 </a:solidFill>
-                <a:latin typeface="Arial"/>
+                <a:latin typeface="Calibri"/>
               </a:defRPr>
             </a:pPr>
             <a:r>
@@ -6451,7 +6631,9 @@
             <a:srgbClr val="2563EB"/>
           </a:solidFill>
           <a:ln>
-            <a:noFill/>
+            <a:solidFill>
+              <a:srgbClr val="2563EB"/>
+            </a:solidFill>
           </a:ln>
         </p:spPr>
         <p:style>
@@ -6495,7 +6677,7 @@
           </a:solidFill>
           <a:ln w="12700">
             <a:solidFill>
-              <a:srgbClr val="E2E8F0"/>
+              <a:srgbClr val="CBD5E1"/>
             </a:solidFill>
           </a:ln>
         </p:spPr>
@@ -6551,7 +6733,7 @@
                 <a:solidFill>
                   <a:srgbClr val="2563EB"/>
                 </a:solidFill>
-                <a:latin typeface="Arial"/>
+                <a:latin typeface="Calibri"/>
               </a:defRPr>
             </a:pPr>
             <a:r>
@@ -6560,11 +6742,14 @@
           </a:p>
           <a:p>
             <a:pPr>
-              <a:defRPr sz="1050">
+              <a:spcAft>
+                <a:spcPts val="400"/>
+              </a:spcAft>
+              <a:defRPr sz="1050" b="0">
                 <a:solidFill>
                   <a:srgbClr val="0F172A"/>
                 </a:solidFill>
-                <a:latin typeface="Arial"/>
+                <a:latin typeface="Calibri"/>
               </a:defRPr>
             </a:pPr>
             <a:r>
@@ -6592,7 +6777,7 @@
           </a:solidFill>
           <a:ln w="12700">
             <a:solidFill>
-              <a:srgbClr val="E2E8F0"/>
+              <a:srgbClr val="CBD5E1"/>
             </a:solidFill>
           </a:ln>
         </p:spPr>
@@ -6648,7 +6833,7 @@
                 <a:solidFill>
                   <a:srgbClr val="2563EB"/>
                 </a:solidFill>
-                <a:latin typeface="Arial"/>
+                <a:latin typeface="Calibri"/>
               </a:defRPr>
             </a:pPr>
             <a:r>
@@ -6657,11 +6842,14 @@
           </a:p>
           <a:p>
             <a:pPr>
-              <a:defRPr sz="1050">
+              <a:spcAft>
+                <a:spcPts val="400"/>
+              </a:spcAft>
+              <a:defRPr sz="1050" b="0">
                 <a:solidFill>
                   <a:srgbClr val="0F172A"/>
                 </a:solidFill>
-                <a:latin typeface="Arial"/>
+                <a:latin typeface="Calibri"/>
               </a:defRPr>
             </a:pPr>
             <a:r>
@@ -6689,7 +6877,7 @@
           </a:solidFill>
           <a:ln w="12700">
             <a:solidFill>
-              <a:srgbClr val="E2E8F0"/>
+              <a:srgbClr val="CBD5E1"/>
             </a:solidFill>
           </a:ln>
         </p:spPr>
@@ -6745,7 +6933,7 @@
                 <a:solidFill>
                   <a:srgbClr val="2563EB"/>
                 </a:solidFill>
-                <a:latin typeface="Arial"/>
+                <a:latin typeface="Calibri"/>
               </a:defRPr>
             </a:pPr>
             <a:r>
@@ -6754,11 +6942,14 @@
           </a:p>
           <a:p>
             <a:pPr>
-              <a:defRPr sz="1050">
+              <a:spcAft>
+                <a:spcPts val="400"/>
+              </a:spcAft>
+              <a:defRPr sz="1050" b="0">
                 <a:solidFill>
                   <a:srgbClr val="0F172A"/>
                 </a:solidFill>
-                <a:latin typeface="Arial"/>
+                <a:latin typeface="Calibri"/>
               </a:defRPr>
             </a:pPr>
             <a:r>
@@ -6786,7 +6977,7 @@
           </a:solidFill>
           <a:ln w="12700">
             <a:solidFill>
-              <a:srgbClr val="E2E8F0"/>
+              <a:srgbClr val="CBD5E1"/>
             </a:solidFill>
           </a:ln>
         </p:spPr>
@@ -6842,7 +7033,7 @@
                 <a:solidFill>
                   <a:srgbClr val="2563EB"/>
                 </a:solidFill>
-                <a:latin typeface="Arial"/>
+                <a:latin typeface="Calibri"/>
               </a:defRPr>
             </a:pPr>
             <a:r>
@@ -6851,11 +7042,14 @@
           </a:p>
           <a:p>
             <a:pPr>
-              <a:defRPr sz="1050">
+              <a:spcAft>
+                <a:spcPts val="400"/>
+              </a:spcAft>
+              <a:defRPr sz="1050" b="0">
                 <a:solidFill>
                   <a:srgbClr val="0F172A"/>
                 </a:solidFill>
-                <a:latin typeface="Arial"/>
+                <a:latin typeface="Calibri"/>
               </a:defRPr>
             </a:pPr>
             <a:r>
@@ -6900,7 +7094,9 @@
             <a:srgbClr val="0F172A"/>
           </a:solidFill>
           <a:ln>
-            <a:noFill/>
+            <a:solidFill>
+              <a:srgbClr val="0F172A"/>
+            </a:solidFill>
           </a:ln>
         </p:spPr>
         <p:style>
@@ -6948,11 +7144,14 @@
           <a:lstStyle/>
           <a:p>
             <a:pPr>
+              <a:spcAft>
+                <a:spcPts val="400"/>
+              </a:spcAft>
               <a:defRPr sz="950" b="1">
                 <a:solidFill>
                   <a:srgbClr val="60A5FA"/>
                 </a:solidFill>
-                <a:latin typeface="Arial"/>
+                <a:latin typeface="Calibri"/>
               </a:defRPr>
             </a:pPr>
             <a:r>
@@ -6984,11 +7183,14 @@
           <a:lstStyle/>
           <a:p>
             <a:pPr>
+              <a:spcAft>
+                <a:spcPts val="400"/>
+              </a:spcAft>
               <a:defRPr sz="2000" b="1">
                 <a:solidFill>
                   <a:srgbClr val="FFFFFF"/>
                 </a:solidFill>
-                <a:latin typeface="Arial"/>
+                <a:latin typeface="Calibri"/>
               </a:defRPr>
             </a:pPr>
             <a:r>
@@ -7015,7 +7217,9 @@
             <a:srgbClr val="2563EB"/>
           </a:solidFill>
           <a:ln>
-            <a:noFill/>
+            <a:solidFill>
+              <a:srgbClr val="2563EB"/>
+            </a:solidFill>
           </a:ln>
         </p:spPr>
         <p:style>
@@ -7059,7 +7263,7 @@
           </a:solidFill>
           <a:ln w="12700">
             <a:solidFill>
-              <a:srgbClr val="E2E8F0"/>
+              <a:srgbClr val="CBD5E1"/>
             </a:solidFill>
           </a:ln>
         </p:spPr>
@@ -7115,7 +7319,7 @@
                 <a:solidFill>
                   <a:srgbClr val="0F172A"/>
                 </a:solidFill>
-                <a:latin typeface="Arial"/>
+                <a:latin typeface="Calibri"/>
               </a:defRPr>
             </a:pPr>
             <a:r>
@@ -7124,7 +7328,10 @@
           </a:p>
           <a:p>
             <a:pPr>
-              <a:defRPr sz="950">
+              <a:spcAft>
+                <a:spcPts val="200"/>
+              </a:spcAft>
+              <a:defRPr sz="950" b="0">
                 <a:solidFill>
                   <a:srgbClr val="1E293B"/>
                 </a:solidFill>
@@ -7134,44 +7341,176 @@
             <a:r>
               <a:t>struct Certificate {</a:t>
             </a:r>
-            <a:br/>
+          </a:p>
+          <a:p>
+            <a:pPr>
+              <a:spcAft>
+                <a:spcPts val="200"/>
+              </a:spcAft>
+              <a:defRPr sz="950" b="0">
+                <a:solidFill>
+                  <a:srgbClr val="1E293B"/>
+                </a:solidFill>
+                <a:latin typeface="Courier New"/>
+              </a:defRPr>
+            </a:pPr>
             <a:r>
               <a:t>    string certificateId;</a:t>
             </a:r>
-            <a:br/>
+          </a:p>
+          <a:p>
+            <a:pPr>
+              <a:spcAft>
+                <a:spcPts val="200"/>
+              </a:spcAft>
+              <a:defRPr sz="950" b="0">
+                <a:solidFill>
+                  <a:srgbClr val="1E293B"/>
+                </a:solidFill>
+                <a:latin typeface="Courier New"/>
+              </a:defRPr>
+            </a:pPr>
             <a:r>
               <a:t>    string certificateHash;  // SHA-256</a:t>
             </a:r>
-            <a:br/>
+          </a:p>
+          <a:p>
+            <a:pPr>
+              <a:spcAft>
+                <a:spcPts val="200"/>
+              </a:spcAft>
+              <a:defRPr sz="950" b="0">
+                <a:solidFill>
+                  <a:srgbClr val="1E293B"/>
+                </a:solidFill>
+                <a:latin typeface="Courier New"/>
+              </a:defRPr>
+            </a:pPr>
             <a:r>
               <a:t>    address issuer;          // Signer</a:t>
             </a:r>
-            <a:br/>
+          </a:p>
+          <a:p>
+            <a:pPr>
+              <a:spcAft>
+                <a:spcPts val="200"/>
+              </a:spcAft>
+              <a:defRPr sz="950" b="0">
+                <a:solidFill>
+                  <a:srgbClr val="1E293B"/>
+                </a:solidFill>
+                <a:latin typeface="Courier New"/>
+              </a:defRPr>
+            </a:pPr>
             <a:r>
               <a:t>    uint256 issueTimestamp;  // Block time</a:t>
             </a:r>
-            <a:br/>
+          </a:p>
+          <a:p>
+            <a:pPr>
+              <a:spcAft>
+                <a:spcPts val="200"/>
+              </a:spcAft>
+              <a:defRPr sz="950" b="0">
+                <a:solidFill>
+                  <a:srgbClr val="1E293B"/>
+                </a:solidFill>
+                <a:latin typeface="Courier New"/>
+              </a:defRPr>
+            </a:pPr>
             <a:r>
               <a:t>    bool isRevoked;</a:t>
             </a:r>
-            <a:br/>
+          </a:p>
+          <a:p>
+            <a:pPr>
+              <a:spcAft>
+                <a:spcPts val="200"/>
+              </a:spcAft>
+              <a:defRPr sz="950" b="0">
+                <a:solidFill>
+                  <a:srgbClr val="1E293B"/>
+                </a:solidFill>
+                <a:latin typeface="Courier New"/>
+              </a:defRPr>
+            </a:pPr>
             <a:r>
               <a:t>    bool exists;</a:t>
             </a:r>
-            <a:br/>
+          </a:p>
+          <a:p>
+            <a:pPr>
+              <a:spcAft>
+                <a:spcPts val="200"/>
+              </a:spcAft>
+              <a:defRPr sz="950" b="0">
+                <a:solidFill>
+                  <a:srgbClr val="1E293B"/>
+                </a:solidFill>
+                <a:latin typeface="Courier New"/>
+              </a:defRPr>
+            </a:pPr>
             <a:r>
               <a:t>}</a:t>
             </a:r>
-            <a:br/>
-            <a:br/>
+          </a:p>
+          <a:p>
+            <a:pPr>
+              <a:spcAft>
+                <a:spcPts val="200"/>
+              </a:spcAft>
+              <a:defRPr sz="950" b="0">
+                <a:solidFill>
+                  <a:srgbClr val="1E293B"/>
+                </a:solidFill>
+                <a:latin typeface="Courier New"/>
+              </a:defRPr>
+            </a:pPr>
+          </a:p>
+          <a:p>
+            <a:pPr>
+              <a:spcAft>
+                <a:spcPts val="200"/>
+              </a:spcAft>
+              <a:defRPr sz="950" b="0">
+                <a:solidFill>
+                  <a:srgbClr val="1E293B"/>
+                </a:solidFill>
+                <a:latin typeface="Courier New"/>
+              </a:defRPr>
+            </a:pPr>
             <a:r>
               <a:t>mapping(string =&gt; Certificate) certificates;</a:t>
             </a:r>
-            <a:br/>
+          </a:p>
+          <a:p>
+            <a:pPr>
+              <a:spcAft>
+                <a:spcPts val="200"/>
+              </a:spcAft>
+              <a:defRPr sz="950" b="0">
+                <a:solidFill>
+                  <a:srgbClr val="1E293B"/>
+                </a:solidFill>
+                <a:latin typeface="Courier New"/>
+              </a:defRPr>
+            </a:pPr>
             <a:r>
               <a:t>event CertificateRegistered(id, hash, issuer);</a:t>
             </a:r>
-            <a:br/>
+          </a:p>
+          <a:p>
+            <a:pPr>
+              <a:spcAft>
+                <a:spcPts val="200"/>
+              </a:spcAft>
+              <a:defRPr sz="950" b="0">
+                <a:solidFill>
+                  <a:srgbClr val="1E293B"/>
+                </a:solidFill>
+                <a:latin typeface="Courier New"/>
+              </a:defRPr>
+            </a:pPr>
             <a:r>
               <a:t>event CertificateRevoked(id, issuer, time);</a:t>
             </a:r>
@@ -7197,7 +7536,7 @@
           </a:solidFill>
           <a:ln w="12700">
             <a:solidFill>
-              <a:srgbClr val="E2E8F0"/>
+              <a:srgbClr val="CBD5E1"/>
             </a:solidFill>
           </a:ln>
         </p:spPr>
@@ -7253,7 +7592,7 @@
                 <a:solidFill>
                   <a:srgbClr val="0F172A"/>
                 </a:solidFill>
-                <a:latin typeface="Arial"/>
+                <a:latin typeface="Calibri"/>
               </a:defRPr>
             </a:pPr>
             <a:r>
@@ -7262,15 +7601,18 @@
           </a:p>
           <a:p>
             <a:pPr>
+              <a:spcAft>
+                <a:spcPts val="200"/>
+              </a:spcAft>
               <a:defRPr sz="1100" b="1">
                 <a:solidFill>
                   <a:srgbClr val="2563EB"/>
                 </a:solidFill>
-                <a:latin typeface="Arial"/>
-              </a:defRPr>
-            </a:pPr>
-            <a:r>
-              <a:t>• registerCertificate(id, hash)</a:t>
+                <a:latin typeface="Calibri"/>
+              </a:defRPr>
+            </a:pPr>
+            <a:r>
+              <a:t>- registerCertificate(id, hash)</a:t>
             </a:r>
           </a:p>
           <a:p>
@@ -7278,11 +7620,11 @@
               <a:spcAft>
                 <a:spcPts val="600"/>
               </a:spcAft>
-              <a:defRPr sz="950">
+              <a:defRPr sz="950" b="0">
                 <a:solidFill>
                   <a:srgbClr val="0F172A"/>
                 </a:solidFill>
-                <a:latin typeface="Arial"/>
+                <a:latin typeface="Calibri"/>
               </a:defRPr>
             </a:pPr>
             <a:r>
@@ -7291,15 +7633,18 @@
           </a:p>
           <a:p>
             <a:pPr>
+              <a:spcAft>
+                <a:spcPts val="200"/>
+              </a:spcAft>
               <a:defRPr sz="1100" b="1">
                 <a:solidFill>
                   <a:srgbClr val="2563EB"/>
                 </a:solidFill>
-                <a:latin typeface="Arial"/>
-              </a:defRPr>
-            </a:pPr>
-            <a:r>
-              <a:t>• verifyCertificate(id, hash)</a:t>
+                <a:latin typeface="Calibri"/>
+              </a:defRPr>
+            </a:pPr>
+            <a:r>
+              <a:t>- verifyCertificate(id, hash)</a:t>
             </a:r>
           </a:p>
           <a:p>
@@ -7307,11 +7652,11 @@
               <a:spcAft>
                 <a:spcPts val="600"/>
               </a:spcAft>
-              <a:defRPr sz="950">
+              <a:defRPr sz="950" b="0">
                 <a:solidFill>
                   <a:srgbClr val="0F172A"/>
                 </a:solidFill>
-                <a:latin typeface="Arial"/>
+                <a:latin typeface="Calibri"/>
               </a:defRPr>
             </a:pPr>
             <a:r>
@@ -7320,15 +7665,18 @@
           </a:p>
           <a:p>
             <a:pPr>
+              <a:spcAft>
+                <a:spcPts val="200"/>
+              </a:spcAft>
               <a:defRPr sz="1100" b="1">
                 <a:solidFill>
                   <a:srgbClr val="2563EB"/>
                 </a:solidFill>
-                <a:latin typeface="Arial"/>
-              </a:defRPr>
-            </a:pPr>
-            <a:r>
-              <a:t>• revokeCertificate(id)</a:t>
+                <a:latin typeface="Calibri"/>
+              </a:defRPr>
+            </a:pPr>
+            <a:r>
+              <a:t>- revokeCertificate(id)</a:t>
             </a:r>
           </a:p>
           <a:p>
@@ -7336,11 +7684,11 @@
               <a:spcAft>
                 <a:spcPts val="600"/>
               </a:spcAft>
-              <a:defRPr sz="950">
+              <a:defRPr sz="950" b="0">
                 <a:solidFill>
                   <a:srgbClr val="0F172A"/>
                 </a:solidFill>
-                <a:latin typeface="Arial"/>
+                <a:latin typeface="Calibri"/>
               </a:defRPr>
             </a:pPr>
             <a:r>
@@ -7349,15 +7697,18 @@
           </a:p>
           <a:p>
             <a:pPr>
+              <a:spcAft>
+                <a:spcPts val="200"/>
+              </a:spcAft>
               <a:defRPr sz="1100" b="1">
                 <a:solidFill>
                   <a:srgbClr val="2563EB"/>
                 </a:solidFill>
-                <a:latin typeface="Arial"/>
-              </a:defRPr>
-            </a:pPr>
-            <a:r>
-              <a:t>• getCertificate(id)</a:t>
+                <a:latin typeface="Calibri"/>
+              </a:defRPr>
+            </a:pPr>
+            <a:r>
+              <a:t>- getCertificate(id)</a:t>
             </a:r>
           </a:p>
           <a:p>
@@ -7365,11 +7716,11 @@
               <a:spcAft>
                 <a:spcPts val="600"/>
               </a:spcAft>
-              <a:defRPr sz="950">
+              <a:defRPr sz="950" b="0">
                 <a:solidFill>
                   <a:srgbClr val="0F172A"/>
                 </a:solidFill>
-                <a:latin typeface="Arial"/>
+                <a:latin typeface="Calibri"/>
               </a:defRPr>
             </a:pPr>
             <a:r>
@@ -7414,7 +7765,9 @@
             <a:srgbClr val="0F172A"/>
           </a:solidFill>
           <a:ln>
-            <a:noFill/>
+            <a:solidFill>
+              <a:srgbClr val="0F172A"/>
+            </a:solidFill>
           </a:ln>
         </p:spPr>
         <p:style>
@@ -7462,11 +7815,14 @@
           <a:lstStyle/>
           <a:p>
             <a:pPr>
+              <a:spcAft>
+                <a:spcPts val="400"/>
+              </a:spcAft>
               <a:defRPr sz="950" b="1">
                 <a:solidFill>
                   <a:srgbClr val="60A5FA"/>
                 </a:solidFill>
-                <a:latin typeface="Arial"/>
+                <a:latin typeface="Calibri"/>
               </a:defRPr>
             </a:pPr>
             <a:r>
@@ -7498,11 +7854,14 @@
           <a:lstStyle/>
           <a:p>
             <a:pPr>
+              <a:spcAft>
+                <a:spcPts val="400"/>
+              </a:spcAft>
               <a:defRPr sz="2000" b="1">
                 <a:solidFill>
                   <a:srgbClr val="FFFFFF"/>
                 </a:solidFill>
-                <a:latin typeface="Arial"/>
+                <a:latin typeface="Calibri"/>
               </a:defRPr>
             </a:pPr>
             <a:r>
@@ -7529,7 +7888,9 @@
             <a:srgbClr val="2563EB"/>
           </a:solidFill>
           <a:ln>
-            <a:noFill/>
+            <a:solidFill>
+              <a:srgbClr val="2563EB"/>
+            </a:solidFill>
           </a:ln>
         </p:spPr>
         <p:style>
@@ -7573,7 +7934,7 @@
           </a:solidFill>
           <a:ln w="12700">
             <a:solidFill>
-              <a:srgbClr val="E2E8F0"/>
+              <a:srgbClr val="CBD5E1"/>
             </a:solidFill>
           </a:ln>
         </p:spPr>
@@ -7629,7 +7990,7 @@
                 <a:solidFill>
                   <a:srgbClr val="2563EB"/>
                 </a:solidFill>
-                <a:latin typeface="Arial"/>
+                <a:latin typeface="Calibri"/>
               </a:defRPr>
             </a:pPr>
             <a:r>
@@ -7638,11 +7999,14 @@
           </a:p>
           <a:p>
             <a:pPr>
-              <a:defRPr sz="1100">
+              <a:spcAft>
+                <a:spcPts val="400"/>
+              </a:spcAft>
+              <a:defRPr sz="1100" b="0">
                 <a:solidFill>
                   <a:srgbClr val="0F172A"/>
                 </a:solidFill>
-                <a:latin typeface="Arial"/>
+                <a:latin typeface="Calibri"/>
               </a:defRPr>
             </a:pPr>
             <a:r>
@@ -7670,7 +8034,7 @@
           </a:solidFill>
           <a:ln w="12700">
             <a:solidFill>
-              <a:srgbClr val="E2E8F0"/>
+              <a:srgbClr val="CBD5E1"/>
             </a:solidFill>
           </a:ln>
         </p:spPr>
@@ -7726,7 +8090,7 @@
                 <a:solidFill>
                   <a:srgbClr val="2563EB"/>
                 </a:solidFill>
-                <a:latin typeface="Arial"/>
+                <a:latin typeface="Calibri"/>
               </a:defRPr>
             </a:pPr>
             <a:r>
@@ -7735,11 +8099,14 @@
           </a:p>
           <a:p>
             <a:pPr>
-              <a:defRPr sz="1100">
+              <a:spcAft>
+                <a:spcPts val="400"/>
+              </a:spcAft>
+              <a:defRPr sz="1100" b="0">
                 <a:solidFill>
                   <a:srgbClr val="0F172A"/>
                 </a:solidFill>
-                <a:latin typeface="Arial"/>
+                <a:latin typeface="Calibri"/>
               </a:defRPr>
             </a:pPr>
             <a:r>
@@ -7767,7 +8134,7 @@
           </a:solidFill>
           <a:ln w="12700">
             <a:solidFill>
-              <a:srgbClr val="E2E8F0"/>
+              <a:srgbClr val="CBD5E1"/>
             </a:solidFill>
           </a:ln>
         </p:spPr>
@@ -7823,7 +8190,7 @@
                 <a:solidFill>
                   <a:srgbClr val="2563EB"/>
                 </a:solidFill>
-                <a:latin typeface="Arial"/>
+                <a:latin typeface="Calibri"/>
               </a:defRPr>
             </a:pPr>
             <a:r>
@@ -7832,11 +8199,14 @@
           </a:p>
           <a:p>
             <a:pPr>
-              <a:defRPr sz="1100">
+              <a:spcAft>
+                <a:spcPts val="400"/>
+              </a:spcAft>
+              <a:defRPr sz="1100" b="0">
                 <a:solidFill>
                   <a:srgbClr val="0F172A"/>
                 </a:solidFill>
-                <a:latin typeface="Arial"/>
+                <a:latin typeface="Calibri"/>
               </a:defRPr>
             </a:pPr>
             <a:r>
@@ -7864,7 +8234,7 @@
           </a:solidFill>
           <a:ln w="12700">
             <a:solidFill>
-              <a:srgbClr val="E2E8F0"/>
+              <a:srgbClr val="CBD5E1"/>
             </a:solidFill>
           </a:ln>
         </p:spPr>
@@ -7920,7 +8290,7 @@
                 <a:solidFill>
                   <a:srgbClr val="2563EB"/>
                 </a:solidFill>
-                <a:latin typeface="Arial"/>
+                <a:latin typeface="Calibri"/>
               </a:defRPr>
             </a:pPr>
             <a:r>
@@ -7929,11 +8299,14 @@
           </a:p>
           <a:p>
             <a:pPr>
-              <a:defRPr sz="1100">
+              <a:spcAft>
+                <a:spcPts val="400"/>
+              </a:spcAft>
+              <a:defRPr sz="1100" b="0">
                 <a:solidFill>
                   <a:srgbClr val="0F172A"/>
                 </a:solidFill>
-                <a:latin typeface="Arial"/>
+                <a:latin typeface="Calibri"/>
               </a:defRPr>
             </a:pPr>
             <a:r>
@@ -7978,7 +8351,9 @@
             <a:srgbClr val="0F172A"/>
           </a:solidFill>
           <a:ln>
-            <a:noFill/>
+            <a:solidFill>
+              <a:srgbClr val="0F172A"/>
+            </a:solidFill>
           </a:ln>
         </p:spPr>
         <p:style>
@@ -8026,11 +8401,14 @@
           <a:lstStyle/>
           <a:p>
             <a:pPr>
+              <a:spcAft>
+                <a:spcPts val="400"/>
+              </a:spcAft>
               <a:defRPr sz="950" b="1">
                 <a:solidFill>
                   <a:srgbClr val="60A5FA"/>
                 </a:solidFill>
-                <a:latin typeface="Arial"/>
+                <a:latin typeface="Calibri"/>
               </a:defRPr>
             </a:pPr>
             <a:r>
@@ -8062,11 +8440,14 @@
           <a:lstStyle/>
           <a:p>
             <a:pPr>
+              <a:spcAft>
+                <a:spcPts val="400"/>
+              </a:spcAft>
               <a:defRPr sz="2000" b="1">
                 <a:solidFill>
                   <a:srgbClr val="FFFFFF"/>
                 </a:solidFill>
-                <a:latin typeface="Arial"/>
+                <a:latin typeface="Calibri"/>
               </a:defRPr>
             </a:pPr>
             <a:r>
@@ -8093,7 +8474,9 @@
             <a:srgbClr val="2563EB"/>
           </a:solidFill>
           <a:ln>
-            <a:noFill/>
+            <a:solidFill>
+              <a:srgbClr val="2563EB"/>
+            </a:solidFill>
           </a:ln>
         </p:spPr>
         <p:style>
@@ -8137,7 +8520,7 @@
           </a:solidFill>
           <a:ln w="12700">
             <a:solidFill>
-              <a:srgbClr val="E2E8F0"/>
+              <a:srgbClr val="CBD5E1"/>
             </a:solidFill>
           </a:ln>
         </p:spPr>
@@ -8172,7 +8555,7 @@
         <p:spPr>
           <a:xfrm>
             <a:off x="1005840" y="1627632"/>
-            <a:ext cx="10149840" cy="1042416"/>
+            <a:ext cx="10149840" cy="1042415"/>
           </a:xfrm>
           <a:prstGeom prst="rect">
             <a:avLst/>
@@ -8193,7 +8576,7 @@
                 <a:solidFill>
                   <a:srgbClr val="2563EB"/>
                 </a:solidFill>
-                <a:latin typeface="Arial"/>
+                <a:latin typeface="Calibri"/>
               </a:defRPr>
             </a:pPr>
             <a:r>
@@ -8202,11 +8585,14 @@
           </a:p>
           <a:p>
             <a:pPr>
-              <a:defRPr sz="1050">
+              <a:spcAft>
+                <a:spcPts val="400"/>
+              </a:spcAft>
+              <a:defRPr sz="1050" b="0">
                 <a:solidFill>
                   <a:srgbClr val="0F172A"/>
                 </a:solidFill>
-                <a:latin typeface="Arial"/>
+                <a:latin typeface="Calibri"/>
               </a:defRPr>
             </a:pPr>
             <a:r>
@@ -8234,7 +8620,7 @@
           </a:solidFill>
           <a:ln w="12700">
             <a:solidFill>
-              <a:srgbClr val="E2E8F0"/>
+              <a:srgbClr val="CBD5E1"/>
             </a:solidFill>
           </a:ln>
         </p:spPr>
@@ -8269,7 +8655,7 @@
         <p:spPr>
           <a:xfrm>
             <a:off x="1005840" y="3273552"/>
-            <a:ext cx="10149840" cy="1042416"/>
+            <a:ext cx="10149840" cy="1042415"/>
           </a:xfrm>
           <a:prstGeom prst="rect">
             <a:avLst/>
@@ -8290,7 +8676,7 @@
                 <a:solidFill>
                   <a:srgbClr val="2563EB"/>
                 </a:solidFill>
-                <a:latin typeface="Arial"/>
+                <a:latin typeface="Calibri"/>
               </a:defRPr>
             </a:pPr>
             <a:r>
@@ -8299,11 +8685,14 @@
           </a:p>
           <a:p>
             <a:pPr>
-              <a:defRPr sz="1050">
+              <a:spcAft>
+                <a:spcPts val="400"/>
+              </a:spcAft>
+              <a:defRPr sz="1050" b="0">
                 <a:solidFill>
                   <a:srgbClr val="0F172A"/>
                 </a:solidFill>
-                <a:latin typeface="Arial"/>
+                <a:latin typeface="Calibri"/>
               </a:defRPr>
             </a:pPr>
             <a:r>
@@ -8331,7 +8720,7 @@
           </a:solidFill>
           <a:ln w="12700">
             <a:solidFill>
-              <a:srgbClr val="E2E8F0"/>
+              <a:srgbClr val="CBD5E1"/>
             </a:solidFill>
           </a:ln>
         </p:spPr>
@@ -8366,7 +8755,7 @@
         <p:spPr>
           <a:xfrm>
             <a:off x="1005840" y="4919472"/>
-            <a:ext cx="10149840" cy="1042416"/>
+            <a:ext cx="10149840" cy="1042415"/>
           </a:xfrm>
           <a:prstGeom prst="rect">
             <a:avLst/>
@@ -8387,7 +8776,7 @@
                 <a:solidFill>
                   <a:srgbClr val="2563EB"/>
                 </a:solidFill>
-                <a:latin typeface="Arial"/>
+                <a:latin typeface="Calibri"/>
               </a:defRPr>
             </a:pPr>
             <a:r>
@@ -8396,11 +8785,14 @@
           </a:p>
           <a:p>
             <a:pPr>
-              <a:defRPr sz="1050">
+              <a:spcAft>
+                <a:spcPts val="400"/>
+              </a:spcAft>
+              <a:defRPr sz="1050" b="0">
                 <a:solidFill>
                   <a:srgbClr val="0F172A"/>
                 </a:solidFill>
-                <a:latin typeface="Arial"/>
+                <a:latin typeface="Calibri"/>
               </a:defRPr>
             </a:pPr>
             <a:r>
@@ -8445,7 +8837,9 @@
             <a:srgbClr val="0F172A"/>
           </a:solidFill>
           <a:ln>
-            <a:noFill/>
+            <a:solidFill>
+              <a:srgbClr val="0F172A"/>
+            </a:solidFill>
           </a:ln>
         </p:spPr>
         <p:style>
@@ -8493,11 +8887,14 @@
           <a:lstStyle/>
           <a:p>
             <a:pPr>
+              <a:spcAft>
+                <a:spcPts val="400"/>
+              </a:spcAft>
               <a:defRPr sz="950" b="1">
                 <a:solidFill>
                   <a:srgbClr val="60A5FA"/>
                 </a:solidFill>
-                <a:latin typeface="Arial"/>
+                <a:latin typeface="Calibri"/>
               </a:defRPr>
             </a:pPr>
             <a:r>
@@ -8529,11 +8926,14 @@
           <a:lstStyle/>
           <a:p>
             <a:pPr>
+              <a:spcAft>
+                <a:spcPts val="400"/>
+              </a:spcAft>
               <a:defRPr sz="2000" b="1">
                 <a:solidFill>
                   <a:srgbClr val="FFFFFF"/>
                 </a:solidFill>
-                <a:latin typeface="Arial"/>
+                <a:latin typeface="Calibri"/>
               </a:defRPr>
             </a:pPr>
             <a:r>
@@ -8560,7 +8960,9 @@
             <a:srgbClr val="2563EB"/>
           </a:solidFill>
           <a:ln>
-            <a:noFill/>
+            <a:solidFill>
+              <a:srgbClr val="2563EB"/>
+            </a:solidFill>
           </a:ln>
         </p:spPr>
         <p:style>
@@ -8604,7 +9006,7 @@
           </a:solidFill>
           <a:ln w="12700">
             <a:solidFill>
-              <a:srgbClr val="E2E8F0"/>
+              <a:srgbClr val="CBD5E1"/>
             </a:solidFill>
           </a:ln>
         </p:spPr>
@@ -8660,7 +9062,7 @@
                 <a:solidFill>
                   <a:srgbClr val="2563EB"/>
                 </a:solidFill>
-                <a:latin typeface="Arial"/>
+                <a:latin typeface="Calibri"/>
               </a:defRPr>
             </a:pPr>
             <a:r>
@@ -8672,15 +9074,15 @@
               <a:spcAft>
                 <a:spcPts val="800"/>
               </a:spcAft>
-              <a:defRPr sz="1100">
+              <a:defRPr sz="1100" b="0">
                 <a:solidFill>
                   <a:srgbClr val="0F172A"/>
                 </a:solidFill>
-                <a:latin typeface="Arial"/>
-              </a:defRPr>
-            </a:pPr>
-            <a:r>
-              <a:t>• React.js 18 (Vite 5)</a:t>
+                <a:latin typeface="Calibri"/>
+              </a:defRPr>
+            </a:pPr>
+            <a:r>
+              <a:t>- React.js 18 (Vite 5)</a:t>
             </a:r>
           </a:p>
           <a:p>
@@ -8688,15 +9090,15 @@
               <a:spcAft>
                 <a:spcPts val="800"/>
               </a:spcAft>
-              <a:defRPr sz="1100">
+              <a:defRPr sz="1100" b="0">
                 <a:solidFill>
                   <a:srgbClr val="0F172A"/>
                 </a:solidFill>
-                <a:latin typeface="Arial"/>
-              </a:defRPr>
-            </a:pPr>
-            <a:r>
-              <a:t>• JavaScript (ES6+)</a:t>
+                <a:latin typeface="Calibri"/>
+              </a:defRPr>
+            </a:pPr>
+            <a:r>
+              <a:t>- JavaScript (ES6+)</a:t>
             </a:r>
           </a:p>
           <a:p>
@@ -8704,15 +9106,15 @@
               <a:spcAft>
                 <a:spcPts val="800"/>
               </a:spcAft>
-              <a:defRPr sz="1100">
+              <a:defRPr sz="1100" b="0">
                 <a:solidFill>
                   <a:srgbClr val="0F172A"/>
                 </a:solidFill>
-                <a:latin typeface="Arial"/>
-              </a:defRPr>
-            </a:pPr>
-            <a:r>
-              <a:t>• Lucide React (Icons)</a:t>
+                <a:latin typeface="Calibri"/>
+              </a:defRPr>
+            </a:pPr>
+            <a:r>
+              <a:t>- Lucide React (Icons)</a:t>
             </a:r>
           </a:p>
           <a:p>
@@ -8720,15 +9122,15 @@
               <a:spcAft>
                 <a:spcPts val="800"/>
               </a:spcAft>
-              <a:defRPr sz="1100">
+              <a:defRPr sz="1100" b="0">
                 <a:solidFill>
                   <a:srgbClr val="0F172A"/>
                 </a:solidFill>
-                <a:latin typeface="Arial"/>
-              </a:defRPr>
-            </a:pPr>
-            <a:r>
-              <a:t>• Custom CSS3 (Light/Navy Theme)</a:t>
+                <a:latin typeface="Calibri"/>
+              </a:defRPr>
+            </a:pPr>
+            <a:r>
+              <a:t>- Custom CSS3 (Light/Navy Theme)</a:t>
             </a:r>
           </a:p>
         </p:txBody>
@@ -8752,7 +9154,7 @@
           </a:solidFill>
           <a:ln w="12700">
             <a:solidFill>
-              <a:srgbClr val="E2E8F0"/>
+              <a:srgbClr val="CBD5E1"/>
             </a:solidFill>
           </a:ln>
         </p:spPr>
@@ -8808,7 +9210,7 @@
                 <a:solidFill>
                   <a:srgbClr val="2563EB"/>
                 </a:solidFill>
-                <a:latin typeface="Arial"/>
+                <a:latin typeface="Calibri"/>
               </a:defRPr>
             </a:pPr>
             <a:r>
@@ -8820,15 +9222,15 @@
               <a:spcAft>
                 <a:spcPts val="800"/>
               </a:spcAft>
-              <a:defRPr sz="1100">
+              <a:defRPr sz="1100" b="0">
                 <a:solidFill>
                   <a:srgbClr val="0F172A"/>
                 </a:solidFill>
-                <a:latin typeface="Arial"/>
-              </a:defRPr>
-            </a:pPr>
-            <a:r>
-              <a:t>• Solidity ^0.8.20</a:t>
+                <a:latin typeface="Calibri"/>
+              </a:defRPr>
+            </a:pPr>
+            <a:r>
+              <a:t>- Solidity ^0.8.20</a:t>
             </a:r>
           </a:p>
           <a:p>
@@ -8836,15 +9238,15 @@
               <a:spcAft>
                 <a:spcPts val="800"/>
               </a:spcAft>
-              <a:defRPr sz="1100">
+              <a:defRPr sz="1100" b="0">
                 <a:solidFill>
                   <a:srgbClr val="0F172A"/>
                 </a:solidFill>
-                <a:latin typeface="Arial"/>
-              </a:defRPr>
-            </a:pPr>
-            <a:r>
-              <a:t>• EVM Compatible</a:t>
+                <a:latin typeface="Calibri"/>
+              </a:defRPr>
+            </a:pPr>
+            <a:r>
+              <a:t>- EVM Compatible</a:t>
             </a:r>
           </a:p>
           <a:p>
@@ -8852,15 +9254,15 @@
               <a:spcAft>
                 <a:spcPts val="800"/>
               </a:spcAft>
-              <a:defRPr sz="1100">
+              <a:defRPr sz="1100" b="0">
                 <a:solidFill>
                   <a:srgbClr val="0F172A"/>
                 </a:solidFill>
-                <a:latin typeface="Arial"/>
-              </a:defRPr>
-            </a:pPr>
-            <a:r>
-              <a:t>• Optimized Compiler (Paris)</a:t>
+                <a:latin typeface="Calibri"/>
+              </a:defRPr>
+            </a:pPr>
+            <a:r>
+              <a:t>- Optimized Compiler (Paris)</a:t>
             </a:r>
           </a:p>
           <a:p>
@@ -8868,15 +9270,15 @@
               <a:spcAft>
                 <a:spcPts val="800"/>
               </a:spcAft>
-              <a:defRPr sz="1100">
+              <a:defRPr sz="1100" b="0">
                 <a:solidFill>
                   <a:srgbClr val="0F172A"/>
                 </a:solidFill>
-                <a:latin typeface="Arial"/>
-              </a:defRPr>
-            </a:pPr>
-            <a:r>
-              <a:t>• Custom Structs &amp; Events</a:t>
+                <a:latin typeface="Calibri"/>
+              </a:defRPr>
+            </a:pPr>
+            <a:r>
+              <a:t>- Custom Structs &amp; Events</a:t>
             </a:r>
           </a:p>
         </p:txBody>
@@ -8900,7 +9302,7 @@
           </a:solidFill>
           <a:ln w="12700">
             <a:solidFill>
-              <a:srgbClr val="E2E8F0"/>
+              <a:srgbClr val="CBD5E1"/>
             </a:solidFill>
           </a:ln>
         </p:spPr>
@@ -8956,7 +9358,7 @@
                 <a:solidFill>
                   <a:srgbClr val="2563EB"/>
                 </a:solidFill>
-                <a:latin typeface="Arial"/>
+                <a:latin typeface="Calibri"/>
               </a:defRPr>
             </a:pPr>
             <a:r>
@@ -8968,15 +9370,15 @@
               <a:spcAft>
                 <a:spcPts val="800"/>
               </a:spcAft>
-              <a:defRPr sz="1100">
+              <a:defRPr sz="1100" b="0">
                 <a:solidFill>
                   <a:srgbClr val="0F172A"/>
                 </a:solidFill>
-                <a:latin typeface="Arial"/>
-              </a:defRPr>
-            </a:pPr>
-            <a:r>
-              <a:t>• Hardhat Local Network</a:t>
+                <a:latin typeface="Calibri"/>
+              </a:defRPr>
+            </a:pPr>
+            <a:r>
+              <a:t>- Hardhat Local Network</a:t>
             </a:r>
           </a:p>
           <a:p>
@@ -8984,15 +9386,15 @@
               <a:spcAft>
                 <a:spcPts val="800"/>
               </a:spcAft>
-              <a:defRPr sz="1100">
+              <a:defRPr sz="1100" b="0">
                 <a:solidFill>
                   <a:srgbClr val="0F172A"/>
                 </a:solidFill>
-                <a:latin typeface="Arial"/>
-              </a:defRPr>
-            </a:pPr>
-            <a:r>
-              <a:t>• Chain ID: 31337</a:t>
+                <a:latin typeface="Calibri"/>
+              </a:defRPr>
+            </a:pPr>
+            <a:r>
+              <a:t>- Chain ID: 31337</a:t>
             </a:r>
           </a:p>
           <a:p>
@@ -9000,15 +9402,15 @@
               <a:spcAft>
                 <a:spcPts val="800"/>
               </a:spcAft>
-              <a:defRPr sz="1100">
+              <a:defRPr sz="1100" b="0">
                 <a:solidFill>
                   <a:srgbClr val="0F172A"/>
                 </a:solidFill>
-                <a:latin typeface="Arial"/>
-              </a:defRPr>
-            </a:pPr>
-            <a:r>
-              <a:t>• JSON-RPC Protocol (8545)</a:t>
+                <a:latin typeface="Calibri"/>
+              </a:defRPr>
+            </a:pPr>
+            <a:r>
+              <a:t>- JSON-RPC Protocol (8545)</a:t>
             </a:r>
           </a:p>
           <a:p>
@@ -9016,15 +9418,15 @@
               <a:spcAft>
                 <a:spcPts val="800"/>
               </a:spcAft>
-              <a:defRPr sz="1100">
+              <a:defRPr sz="1100" b="0">
                 <a:solidFill>
                   <a:srgbClr val="0F172A"/>
                 </a:solidFill>
-                <a:latin typeface="Arial"/>
-              </a:defRPr>
-            </a:pPr>
-            <a:r>
-              <a:t>• MetaMask Wallet Integration</a:t>
+                <a:latin typeface="Calibri"/>
+              </a:defRPr>
+            </a:pPr>
+            <a:r>
+              <a:t>- MetaMask Wallet Integration</a:t>
             </a:r>
           </a:p>
         </p:txBody>
@@ -9048,7 +9450,7 @@
           </a:solidFill>
           <a:ln w="12700">
             <a:solidFill>
-              <a:srgbClr val="E2E8F0"/>
+              <a:srgbClr val="CBD5E1"/>
             </a:solidFill>
           </a:ln>
         </p:spPr>
@@ -9104,7 +9506,7 @@
                 <a:solidFill>
                   <a:srgbClr val="2563EB"/>
                 </a:solidFill>
-                <a:latin typeface="Arial"/>
+                <a:latin typeface="Calibri"/>
               </a:defRPr>
             </a:pPr>
             <a:r>
@@ -9116,15 +9518,15 @@
               <a:spcAft>
                 <a:spcPts val="800"/>
               </a:spcAft>
-              <a:defRPr sz="1100">
+              <a:defRPr sz="1100" b="0">
                 <a:solidFill>
                   <a:srgbClr val="0F172A"/>
                 </a:solidFill>
-                <a:latin typeface="Arial"/>
-              </a:defRPr>
-            </a:pPr>
-            <a:r>
-              <a:t>• Ethers.js (v6)</a:t>
+                <a:latin typeface="Calibri"/>
+              </a:defRPr>
+            </a:pPr>
+            <a:r>
+              <a:t>- Ethers.js (v6)</a:t>
             </a:r>
           </a:p>
           <a:p>
@@ -9132,15 +9534,15 @@
               <a:spcAft>
                 <a:spcPts val="800"/>
               </a:spcAft>
-              <a:defRPr sz="1100">
+              <a:defRPr sz="1100" b="0">
                 <a:solidFill>
                   <a:srgbClr val="0F172A"/>
                 </a:solidFill>
-                <a:latin typeface="Arial"/>
-              </a:defRPr>
-            </a:pPr>
-            <a:r>
-              <a:t>• Mocha Test Framework</a:t>
+                <a:latin typeface="Calibri"/>
+              </a:defRPr>
+            </a:pPr>
+            <a:r>
+              <a:t>- Mocha Test Framework</a:t>
             </a:r>
           </a:p>
           <a:p>
@@ -9148,15 +9550,15 @@
               <a:spcAft>
                 <a:spcPts val="800"/>
               </a:spcAft>
-              <a:defRPr sz="1100">
+              <a:defRPr sz="1100" b="0">
                 <a:solidFill>
                   <a:srgbClr val="0F172A"/>
                 </a:solidFill>
-                <a:latin typeface="Arial"/>
-              </a:defRPr>
-            </a:pPr>
-            <a:r>
-              <a:t>• Chai Assertion Library</a:t>
+                <a:latin typeface="Calibri"/>
+              </a:defRPr>
+            </a:pPr>
+            <a:r>
+              <a:t>- Chai Assertion Library</a:t>
             </a:r>
           </a:p>
           <a:p>
@@ -9164,15 +9566,15 @@
               <a:spcAft>
                 <a:spcPts val="800"/>
               </a:spcAft>
-              <a:defRPr sz="1100">
+              <a:defRPr sz="1100" b="0">
                 <a:solidFill>
                   <a:srgbClr val="0F172A"/>
                 </a:solidFill>
-                <a:latin typeface="Arial"/>
-              </a:defRPr>
-            </a:pPr>
-            <a:r>
-              <a:t>• Browser localStorage</a:t>
+                <a:latin typeface="Calibri"/>
+              </a:defRPr>
+            </a:pPr>
+            <a:r>
+              <a:t>- Browser localStorage</a:t>
             </a:r>
           </a:p>
         </p:txBody>

</xml_diff>